<commit_message>
deck 2-2-2: SECTION everywhere, and the badge row reflowed to carry it
The three new breaks spelled SECTION N while the deck still said §N on slide
4's badges, on slide 20, and in slide 26's prose. One deck, two notations, is
worse than either -- so the notation is now SECTION throughout.

Slide 4's badges could not take the word at their shipped size: "SECTION 1" at
14pt needs ~1.05" and the chips were 0.55", with the title column starting at
1.35". So the row is reflowed -- chips 0.55 -> 1.15", title column 1.35 ->
2.00". The right-hand gloss column at 5.80" is untouched, which leaves the
titles 3.80" and no reflow of their own. Rendered and checked by eye.

Slide 20's "§4 — Reasoning with SysML and KerML" and slide 26's "§3's model
named..." are plain prose with room to spare; both read "Section" now.

One § remains, in slide 11's body prose, where it is incidental rather than a
section reference.
</commit_message>
<xml_diff>
--- a/course/lectures/act-2-delegation-and-control/02-modeling/2-2-Modeling-2-Degrees-of-Semantic-Commitment.pptx
+++ b/course/lectures/act-2-delegation-and-control/02-modeling/2-2-Modeling-2-Degrees-of-Semantic-Commitment.pptx
@@ -14396,7 +14396,7 @@
                 </a:solidFill>
                 <a:latin typeface="Calibri"/>
               </a:rPr>
-              <a:t>§4 — Reasoning with SysML and KerML</a:t>
+              <a:t>Section 4 — Reasoning with SysML and KerML</a:t>
             </a:r>
           </a:p>
         </p:txBody>
@@ -19439,7 +19439,7 @@
                 </a:solidFill>
                 <a:latin typeface="Calibri"/>
               </a:rPr>
-              <a:t>§3's model named its missing distinction — operating modes. §4 modeled them — and still
+              <a:t>Section 3's model named its missing distinction — operating modes. §4 modeled them — and still
 has a boundary. </a:t>
             </a:r>
             <a:r>
@@ -20936,7 +20936,7 @@
         <p:spPr>
           <a:xfrm>
             <a:off x="548640" y="3017520"/>
-            <a:ext cx="502920" cy="566928"/>
+            <a:ext cx="1051560" cy="566928"/>
           </a:xfrm>
           <a:prstGeom prst="rect">
             <a:avLst/>
@@ -20975,7 +20975,7 @@
                 </a:solidFill>
                 <a:latin typeface="Calibri"/>
               </a:rPr>
-              <a:t>§1</a:t>
+              <a:t>SECTION 1</a:t>
             </a:r>
           </a:p>
         </p:txBody>
@@ -20988,7 +20988,7 @@
         </p:nvSpPr>
         <p:spPr>
           <a:xfrm>
-            <a:off x="1234440" y="3017520"/>
+            <a:off x="1828800" y="3017520"/>
             <a:ext cx="3931920" cy="566928"/>
           </a:xfrm>
           <a:prstGeom prst="rect">
@@ -21063,7 +21063,7 @@
         <p:spPr>
           <a:xfrm>
             <a:off x="548640" y="3749039"/>
-            <a:ext cx="502920" cy="566928"/>
+            <a:ext cx="1051560" cy="566928"/>
           </a:xfrm>
           <a:prstGeom prst="rect">
             <a:avLst/>
@@ -21102,7 +21102,7 @@
                 </a:solidFill>
                 <a:latin typeface="Calibri"/>
               </a:rPr>
-              <a:t>§2</a:t>
+              <a:t>SECTION 2</a:t>
             </a:r>
           </a:p>
         </p:txBody>
@@ -21115,7 +21115,7 @@
         </p:nvSpPr>
         <p:spPr>
           <a:xfrm>
-            <a:off x="1234440" y="3749039"/>
+            <a:off x="1828800" y="3749039"/>
             <a:ext cx="3931920" cy="566928"/>
           </a:xfrm>
           <a:prstGeom prst="rect">
@@ -21190,7 +21190,7 @@
         <p:spPr>
           <a:xfrm>
             <a:off x="548640" y="4480559"/>
-            <a:ext cx="502920" cy="566928"/>
+            <a:ext cx="1051560" cy="566928"/>
           </a:xfrm>
           <a:prstGeom prst="rect">
             <a:avLst/>
@@ -21229,7 +21229,7 @@
                 </a:solidFill>
                 <a:latin typeface="Calibri"/>
               </a:rPr>
-              <a:t>§3</a:t>
+              <a:t>SECTION 3</a:t>
             </a:r>
           </a:p>
         </p:txBody>
@@ -21242,7 +21242,7 @@
         </p:nvSpPr>
         <p:spPr>
           <a:xfrm>
-            <a:off x="1234440" y="4480559"/>
+            <a:off x="1828800" y="4480559"/>
             <a:ext cx="3931920" cy="566928"/>
           </a:xfrm>
           <a:prstGeom prst="rect">
@@ -21333,7 +21333,7 @@
         <p:spPr>
           <a:xfrm>
             <a:off x="548640" y="5212079"/>
-            <a:ext cx="502920" cy="566928"/>
+            <a:ext cx="1051560" cy="566928"/>
           </a:xfrm>
           <a:prstGeom prst="rect">
             <a:avLst/>
@@ -21372,7 +21372,7 @@
                 </a:solidFill>
                 <a:latin typeface="Calibri"/>
               </a:rPr>
-              <a:t>§4</a:t>
+              <a:t>SECTION 4</a:t>
             </a:r>
           </a:p>
         </p:txBody>
@@ -21385,7 +21385,7 @@
         </p:nvSpPr>
         <p:spPr>
           <a:xfrm>
-            <a:off x="1234440" y="5212079"/>
+            <a:off x="1828800" y="5212079"/>
             <a:ext cx="3931920" cy="566928"/>
           </a:xfrm>
           <a:prstGeom prst="rect">

</xml_diff>